<commit_message>
Align HIL stand with SENTRY sonar and valve module
</commit_message>
<xml_diff>
--- a/docs/presentation/SENTRY_SWM2_QA.pptx
+++ b/docs/presentation/SENTRY_SWM2_QA.pptx
@@ -2,21 +2,21 @@
 <file path=ppt/presentation.xml><?xml version="1.0" encoding="utf-8"?>
 <p:presentation xmlns:p="http://schemas.openxmlformats.org/presentationml/2006/main">
   <p:sldMasterIdLst>
-    <p:sldMasterId xmlns:r="http://schemas.openxmlformats.org/officeDocument/2006/relationships" id="2147483648" r:id="R4f78361e16be495e"/>
+    <p:sldMasterId xmlns:r="http://schemas.openxmlformats.org/officeDocument/2006/relationships" id="2147483648" r:id="R175d7a4d567042dd"/>
   </p:sldMasterIdLst>
   <p:notesMasterIdLst>
-    <p:notesMasterId xmlns:r="http://schemas.openxmlformats.org/officeDocument/2006/relationships" r:id="R032fea57ab7c4626"/>
+    <p:notesMasterId xmlns:r="http://schemas.openxmlformats.org/officeDocument/2006/relationships" r:id="Ra20ea0f4e6de4122"/>
   </p:notesMasterIdLst>
   <p:sldIdLst>
-    <p:sldId xmlns:r="http://schemas.openxmlformats.org/officeDocument/2006/relationships" id="256" r:id="R8b1e3d91ddd24315"/>
-    <p:sldId xmlns:r="http://schemas.openxmlformats.org/officeDocument/2006/relationships" id="257" r:id="R169136cf44284e12"/>
-    <p:sldId xmlns:r="http://schemas.openxmlformats.org/officeDocument/2006/relationships" id="258" r:id="R0c393d83537a49c8"/>
-    <p:sldId xmlns:r="http://schemas.openxmlformats.org/officeDocument/2006/relationships" id="259" r:id="R032a7b5017ab4ee3"/>
-    <p:sldId xmlns:r="http://schemas.openxmlformats.org/officeDocument/2006/relationships" id="260" r:id="R47caadf81727403a"/>
-    <p:sldId xmlns:r="http://schemas.openxmlformats.org/officeDocument/2006/relationships" id="261" r:id="R94bbdae9bfa947d0"/>
-    <p:sldId xmlns:r="http://schemas.openxmlformats.org/officeDocument/2006/relationships" id="262" r:id="Rdf628b55ec8547f5"/>
-    <p:sldId xmlns:r="http://schemas.openxmlformats.org/officeDocument/2006/relationships" id="263" r:id="R5c23f66bbf5846dc"/>
-    <p:sldId xmlns:r="http://schemas.openxmlformats.org/officeDocument/2006/relationships" id="264" r:id="R4668269245474def"/>
+    <p:sldId xmlns:r="http://schemas.openxmlformats.org/officeDocument/2006/relationships" id="256" r:id="R3e67400028fe460b"/>
+    <p:sldId xmlns:r="http://schemas.openxmlformats.org/officeDocument/2006/relationships" id="257" r:id="Rffc2e9bc025049f8"/>
+    <p:sldId xmlns:r="http://schemas.openxmlformats.org/officeDocument/2006/relationships" id="258" r:id="Re956adbb559c47e8"/>
+    <p:sldId xmlns:r="http://schemas.openxmlformats.org/officeDocument/2006/relationships" id="259" r:id="R4fea5c342c484c67"/>
+    <p:sldId xmlns:r="http://schemas.openxmlformats.org/officeDocument/2006/relationships" id="260" r:id="R9cc14a470c784711"/>
+    <p:sldId xmlns:r="http://schemas.openxmlformats.org/officeDocument/2006/relationships" id="261" r:id="Re8c7515484764b4a"/>
+    <p:sldId xmlns:r="http://schemas.openxmlformats.org/officeDocument/2006/relationships" id="262" r:id="Rb01eaa1d787e4a98"/>
+    <p:sldId xmlns:r="http://schemas.openxmlformats.org/officeDocument/2006/relationships" id="263" r:id="R52e5646e3c1d463c"/>
+    <p:sldId xmlns:r="http://schemas.openxmlformats.org/officeDocument/2006/relationships" id="264" r:id="Rd68084c273194b35"/>
   </p:sldIdLst>
   <p:sldSz cx="12192000" cy="6858000"/>
   <p:notesSz cx="6858000" cy="9144000"/>
@@ -1015,7 +1015,12 @@
           </a:p>
           <a:p xmlns:a="http://schemas.openxmlformats.org/drawingml/2006/main">
             <a:r>
-              <a:t>https://github.com/rpozniak/sentry-swm2-qa/blob/main/docs/assets/HIL_STAND.png</a:t>
+              <a:t>https://github.com/rpozniak/sentry-swm2-qa/blob/main/reference/PRD.md</a:t>
+            </a:r>
+          </a:p>
+          <a:p xmlns:a="http://schemas.openxmlformats.org/drawingml/2006/main">
+            <a:r>
+              <a:t>MG90S є допоміжним макетом приводу клапана. PWM формує агент RP2040; очікування для SENTRY визначені в PRD.</a:t>
             </a:r>
           </a:p>
         </p:txBody>
@@ -3533,12 +3538,12 @@
   </p:cSld>
   <p:clrMap bg1="lt1" tx1="dk1" bg2="lt2" tx2="dk2" accent1="accent1" accent2="accent2" accent3="accent3" accent4="accent4" accent5="accent5" accent6="accent6" hlink="hlink" folHlink="folHlink"/>
   <p:sldLayoutIdLst>
-    <p:sldLayoutId xmlns:r="http://schemas.openxmlformats.org/officeDocument/2006/relationships" id="2147483649" r:id="R24f360ae879d4c43"/>
-    <p:sldLayoutId xmlns:r="http://schemas.openxmlformats.org/officeDocument/2006/relationships" id="2147483650" r:id="R06a99e552d994c7f"/>
-    <p:sldLayoutId xmlns:r="http://schemas.openxmlformats.org/officeDocument/2006/relationships" id="2147483651" r:id="R30d280750cf9405d"/>
-    <p:sldLayoutId xmlns:r="http://schemas.openxmlformats.org/officeDocument/2006/relationships" id="2147483652" r:id="Rcfdd64de82b74e17"/>
-    <p:sldLayoutId xmlns:r="http://schemas.openxmlformats.org/officeDocument/2006/relationships" id="2147483653" r:id="R01b1f19d3cc446ea"/>
-    <p:sldLayoutId xmlns:r="http://schemas.openxmlformats.org/officeDocument/2006/relationships" id="2147483654" r:id="Rcfa0b0f77c994328"/>
+    <p:sldLayoutId xmlns:r="http://schemas.openxmlformats.org/officeDocument/2006/relationships" id="2147483649" r:id="Rb23bf70817b14a1d"/>
+    <p:sldLayoutId xmlns:r="http://schemas.openxmlformats.org/officeDocument/2006/relationships" id="2147483650" r:id="R8c3621e80e7e4386"/>
+    <p:sldLayoutId xmlns:r="http://schemas.openxmlformats.org/officeDocument/2006/relationships" id="2147483651" r:id="R19d92a84c3c546c5"/>
+    <p:sldLayoutId xmlns:r="http://schemas.openxmlformats.org/officeDocument/2006/relationships" id="2147483652" r:id="R49f155930c994c11"/>
+    <p:sldLayoutId xmlns:r="http://schemas.openxmlformats.org/officeDocument/2006/relationships" id="2147483653" r:id="R57f4c1ce4aa64206"/>
+    <p:sldLayoutId xmlns:r="http://schemas.openxmlformats.org/officeDocument/2006/relationships" id="2147483654" r:id="R96a7d3756adb40e5"/>
   </p:sldLayoutIdLst>
   <p:txStyles>
     <p:titleStyle>
@@ -5601,7 +5606,7 @@
           <p:nvPr/>
         </p:nvPicPr>
         <p:blipFill>
-          <a:blip xmlns:r="http://schemas.openxmlformats.org/officeDocument/2006/relationships" xmlns:a="http://schemas.openxmlformats.org/drawingml/2006/main" r:embed="R3ba8d3705248470f"/>
+          <a:blip xmlns:r="http://schemas.openxmlformats.org/officeDocument/2006/relationships" xmlns:a="http://schemas.openxmlformats.org/drawingml/2006/main" r:embed="Rd639d99c9e3841fc"/>
           <a:stretch xmlns:a="http://schemas.openxmlformats.org/drawingml/2006/main"/>
         </p:blipFill>
         <p:spPr>
@@ -12971,7 +12976,7 @@
           <p:nvPr/>
         </p:nvPicPr>
         <p:blipFill>
-          <a:blip xmlns:r="http://schemas.openxmlformats.org/officeDocument/2006/relationships" xmlns:a="http://schemas.openxmlformats.org/drawingml/2006/main" r:embed="R3a686045c2414e95"/>
+          <a:blip xmlns:r="http://schemas.openxmlformats.org/officeDocument/2006/relationships" xmlns:a="http://schemas.openxmlformats.org/drawingml/2006/main" r:embed="R473c1dfaea1e42dc"/>
           <a:stretch xmlns:a="http://schemas.openxmlformats.org/drawingml/2006/main"/>
         </p:blipFill>
         <p:spPr>
@@ -13291,7 +13296,7 @@
                 <a:ea typeface="Arial"/>
                 <a:cs typeface="Arial"/>
               </a:rPr>
-              <a:t>RP2040 імітує кнопки</a:t>
+              <a:t>RP2040: кнопки</a:t>
             </a:r>
           </a:p>
           <a:p xmlns:a="http://schemas.openxmlformats.org/drawingml/2006/main">
@@ -13314,7 +13319,7 @@
                 <a:ea typeface="Arial"/>
                 <a:cs typeface="Arial"/>
               </a:rPr>
-              <a:t>та ECHO датчика</a:t>
+              <a:t>та ECHO сонара</a:t>
             </a:r>
           </a:p>
         </p:txBody>
@@ -13470,7 +13475,7 @@
                 <a:ea typeface="Arial"/>
                 <a:cs typeface="Arial"/>
               </a:rPr>
-              <a:t>Контакти, LED і кінцевики</a:t>
+              <a:t>Реле → макет клапана</a:t>
             </a:r>
           </a:p>
           <a:p xmlns:a="http://schemas.openxmlformats.org/drawingml/2006/main">
@@ -13493,7 +13498,7 @@
                 <a:ea typeface="Arial"/>
                 <a:cs typeface="Arial"/>
               </a:rPr>
-              <a:t>дають зворотний зв’язок</a:t>
+              <a:t>MG90S + кінцевики</a:t>
             </a:r>
           </a:p>
         </p:txBody>

</xml_diff>

<commit_message>
Record passing manual relay and indicator checks on 2.3.0
</commit_message>
<xml_diff>
--- a/docs/presentation/SENTRY_SWM2_QA.pptx
+++ b/docs/presentation/SENTRY_SWM2_QA.pptx
@@ -2,22 +2,22 @@
 <file path=ppt/presentation.xml><?xml version="1.0" encoding="utf-8"?>
 <p:presentation xmlns:p="http://schemas.openxmlformats.org/presentationml/2006/main">
   <p:sldMasterIdLst>
-    <p:sldMasterId xmlns:r="http://schemas.openxmlformats.org/officeDocument/2006/relationships" id="2147483648" r:id="Raee74c157d194f94"/>
+    <p:sldMasterId xmlns:r="http://schemas.openxmlformats.org/officeDocument/2006/relationships" id="2147483648" r:id="R5bc24f22e95e47c5"/>
   </p:sldMasterIdLst>
   <p:notesMasterIdLst>
-    <p:notesMasterId xmlns:r="http://schemas.openxmlformats.org/officeDocument/2006/relationships" r:id="R922357230b7f4cd1"/>
+    <p:notesMasterId xmlns:r="http://schemas.openxmlformats.org/officeDocument/2006/relationships" r:id="R6fbcf4d7969e4ca0"/>
   </p:notesMasterIdLst>
   <p:sldIdLst>
-    <p:sldId xmlns:r="http://schemas.openxmlformats.org/officeDocument/2006/relationships" id="256" r:id="R3927c892008c4936"/>
-    <p:sldId xmlns:r="http://schemas.openxmlformats.org/officeDocument/2006/relationships" id="257" r:id="Rd34a9ed1f8b64665"/>
-    <p:sldId xmlns:r="http://schemas.openxmlformats.org/officeDocument/2006/relationships" id="258" r:id="R6742a008b18d4231"/>
-    <p:sldId xmlns:r="http://schemas.openxmlformats.org/officeDocument/2006/relationships" id="259" r:id="R9445e41b77584a44"/>
-    <p:sldId xmlns:r="http://schemas.openxmlformats.org/officeDocument/2006/relationships" id="260" r:id="R0b28db2cf43049e3"/>
-    <p:sldId xmlns:r="http://schemas.openxmlformats.org/officeDocument/2006/relationships" id="261" r:id="R8fdf6988f7114dc7"/>
-    <p:sldId xmlns:r="http://schemas.openxmlformats.org/officeDocument/2006/relationships" id="262" r:id="Rb0b28ff8608549b3"/>
-    <p:sldId xmlns:r="http://schemas.openxmlformats.org/officeDocument/2006/relationships" id="263" r:id="Rea4c79b1e47a4eab"/>
-    <p:sldId xmlns:r="http://schemas.openxmlformats.org/officeDocument/2006/relationships" id="264" r:id="R2da40d0dd88f4aa8"/>
-    <p:sldId xmlns:r="http://schemas.openxmlformats.org/officeDocument/2006/relationships" id="265" r:id="R2f7e6def86864698"/>
+    <p:sldId xmlns:r="http://schemas.openxmlformats.org/officeDocument/2006/relationships" id="256" r:id="R25fb744ae368473b"/>
+    <p:sldId xmlns:r="http://schemas.openxmlformats.org/officeDocument/2006/relationships" id="257" r:id="R11d7e20b9713486a"/>
+    <p:sldId xmlns:r="http://schemas.openxmlformats.org/officeDocument/2006/relationships" id="258" r:id="R4748f54bc3e648ab"/>
+    <p:sldId xmlns:r="http://schemas.openxmlformats.org/officeDocument/2006/relationships" id="259" r:id="R8552bcf705024313"/>
+    <p:sldId xmlns:r="http://schemas.openxmlformats.org/officeDocument/2006/relationships" id="260" r:id="Re55aa2d2ccd0463c"/>
+    <p:sldId xmlns:r="http://schemas.openxmlformats.org/officeDocument/2006/relationships" id="261" r:id="R9143af164862423f"/>
+    <p:sldId xmlns:r="http://schemas.openxmlformats.org/officeDocument/2006/relationships" id="262" r:id="R7e57bdb79eba4d8a"/>
+    <p:sldId xmlns:r="http://schemas.openxmlformats.org/officeDocument/2006/relationships" id="263" r:id="R2434542c7f8748ea"/>
+    <p:sldId xmlns:r="http://schemas.openxmlformats.org/officeDocument/2006/relationships" id="264" r:id="R3dd0c6fda5bd42c6"/>
+    <p:sldId xmlns:r="http://schemas.openxmlformats.org/officeDocument/2006/relationships" id="265" r:id="R442b7957f3284a9e"/>
   </p:sldIdLst>
   <p:sldSz cx="12192000" cy="6858000"/>
   <p:notesSz cx="6858000" cy="9144000"/>
@@ -534,6 +534,11 @@
               <a:t>https://github.com/rpozniak/sentry-swm2-qa/blob/main/docs/TRACEABILITY.md</a:t>
             </a:r>
           </a:p>
+          <a:p xmlns:a="http://schemas.openxmlformats.org/drawingml/2006/main">
+            <a:r>
+              <a:t>Ручний прогін 2.3.0, 24.10.2026: TC-RL-02 і TC-RL-03 — Pass за повідомленням виконавця про відповідність усім умовам. Результат включає ON/OFF для обох пар COM–NO/COM–NC і зовнішнього LED. Фото стенда показує обладнання та LED при ON. Окремого UART-логу або відео прозвонювання не надано. Джерело: logs/manual-2.3.0-01/OPERATOR_REPORT.md. TC-LM-09 і TC-LM-10 на 2.3.0 залишаються Not Run. На 2.1.0 усі чотири ручні кейси — Not Run. Підсумок за кейсами 2.3.0: 30 Pass, 3 Fail, 2 Not Run, 1 N/A. Автоматизовані результати та NO-GO не змінені.</a:t>
+            </a:r>
+          </a:p>
         </p:txBody>
       </p:sp>
       <p:sp>
@@ -836,7 +841,12 @@
           <a:lstStyle xmlns:a="http://schemas.openxmlformats.org/drawingml/2006/main"/>
           <a:p xmlns:a="http://schemas.openxmlformats.org/drawingml/2006/main">
             <a:r>
-              <a:t>Фото надав автор проєкту 24.10.2026. Оригінал: docs/assets/REAL_STAND_2026-10-24.jpg. Опис: docs/REAL_STAND.md. Автор підтвердив реле 5 В, Raspberry Pi 5, ESP32-S3, кнопки, датчик відстані, LED із резистором 220 Ом і мультиметр у режимі прозвонювання. Підключення за описом користувача: живлення модуля від Pi, IN з GPIO8 ESP32. Автор повідомив про спрацювання реле під час підготовки. Фото не змінює результатів фізичних кейсів. Журнал: docs/MANUAL_RUN.md. Поточний ручний стенд відрізняється від проєкту подальшої HIL-автоматизації на окремому слайді.</a:t>
+              <a:t>Фото надав автор проєкту 24.10.2026. Оригінал: docs/assets/REAL_STAND_2026-10-24.jpg. Опис: docs/REAL_STAND.md. Автор підтвердив реле 5 В, Raspberry Pi 5, ESP32-S3, кнопки, датчик відстані, LED із резистором 220 Ом і мультиметр у режимі прозвонювання. Підключення за описом користувача: живлення модуля від Pi, IN з GPIO8 ESP32. Автор підтвердив відповідність перевірок контактів і зовнішнього LED очікуванням. Журнал: docs/MANUAL_RUN.md. Поточний ручний стенд відрізняється від проєкту подальшої HIL-автоматизації на окремому слайді.</a:t>
+            </a:r>
+          </a:p>
+          <a:p xmlns:a="http://schemas.openxmlformats.org/drawingml/2006/main">
+            <a:r>
+              <a:t>Ручний прогін 2.3.0, 24.10.2026: TC-RL-02 і TC-RL-03 — Pass за повідомленням виконавця про відповідність усім умовам. Результат включає ON/OFF для обох пар COM–NO/COM–NC і зовнішнього LED. Фото стенда показує обладнання та LED при ON. Окремого UART-логу або відео прозвонювання не надано. Джерело: logs/manual-2.3.0-01/OPERATOR_REPORT.md. TC-LM-09 і TC-LM-10 на 2.3.0 залишаються Not Run. На 2.1.0 усі чотири ручні кейси — Not Run. Підсумок за кейсами 2.3.0: 30 Pass, 3 Fail, 2 Not Run, 1 N/A. Автоматизовані результати та NO-GO не змінені.</a:t>
             </a:r>
           </a:p>
         </p:txBody>
@@ -987,6 +997,11 @@
           <a:p xmlns:a="http://schemas.openxmlformats.org/drawingml/2006/main">
             <a:r>
               <a:t>https://github.com/rpozniak/sentry-swm2-qa/blob/main/docs/EXECUTION_RESULTS.md</a:t>
+            </a:r>
+          </a:p>
+          <a:p xmlns:a="http://schemas.openxmlformats.org/drawingml/2006/main">
+            <a:r>
+              <a:t>Ручний прогін 2.3.0, 24.10.2026: TC-RL-02 і TC-RL-03 — Pass за повідомленням виконавця про відповідність усім умовам. Результат включає ON/OFF для обох пар COM–NO/COM–NC і зовнішнього LED. Фото стенда показує обладнання та LED при ON. Окремого UART-логу або відео прозвонювання не надано. Джерело: logs/manual-2.3.0-01/OPERATOR_REPORT.md. TC-LM-09 і TC-LM-10 на 2.3.0 залишаються Not Run. На 2.1.0 усі чотири ручні кейси — Not Run. Підсумок за кейсами 2.3.0: 30 Pass, 3 Fail, 2 Not Run, 1 N/A. Автоматизовані результати та NO-GO не змінені.</a:t>
             </a:r>
           </a:p>
         </p:txBody>
@@ -3609,12 +3624,12 @@
   </p:cSld>
   <p:clrMap bg1="lt1" tx1="dk1" bg2="lt2" tx2="dk2" accent1="accent1" accent2="accent2" accent3="accent3" accent4="accent4" accent5="accent5" accent6="accent6" hlink="hlink" folHlink="folHlink"/>
   <p:sldLayoutIdLst>
-    <p:sldLayoutId xmlns:r="http://schemas.openxmlformats.org/officeDocument/2006/relationships" id="2147483649" r:id="Re89360c9c0d34a54"/>
-    <p:sldLayoutId xmlns:r="http://schemas.openxmlformats.org/officeDocument/2006/relationships" id="2147483650" r:id="R28abbaa3e83444dd"/>
-    <p:sldLayoutId xmlns:r="http://schemas.openxmlformats.org/officeDocument/2006/relationships" id="2147483651" r:id="Ra6e2a3a548f64d6d"/>
-    <p:sldLayoutId xmlns:r="http://schemas.openxmlformats.org/officeDocument/2006/relationships" id="2147483652" r:id="Rea3de692778648f8"/>
-    <p:sldLayoutId xmlns:r="http://schemas.openxmlformats.org/officeDocument/2006/relationships" id="2147483653" r:id="R2b8138ce5f944070"/>
-    <p:sldLayoutId xmlns:r="http://schemas.openxmlformats.org/officeDocument/2006/relationships" id="2147483654" r:id="R7aa6d1f762f34796"/>
+    <p:sldLayoutId xmlns:r="http://schemas.openxmlformats.org/officeDocument/2006/relationships" id="2147483649" r:id="Rc5f9c11d28784848"/>
+    <p:sldLayoutId xmlns:r="http://schemas.openxmlformats.org/officeDocument/2006/relationships" id="2147483650" r:id="R17b06670b6614e81"/>
+    <p:sldLayoutId xmlns:r="http://schemas.openxmlformats.org/officeDocument/2006/relationships" id="2147483651" r:id="R1881d436e7784b73"/>
+    <p:sldLayoutId xmlns:r="http://schemas.openxmlformats.org/officeDocument/2006/relationships" id="2147483652" r:id="R21f8e35de54c45ba"/>
+    <p:sldLayoutId xmlns:r="http://schemas.openxmlformats.org/officeDocument/2006/relationships" id="2147483653" r:id="Rc51e8588ff0e4692"/>
+    <p:sldLayoutId xmlns:r="http://schemas.openxmlformats.org/officeDocument/2006/relationships" id="2147483654" r:id="R4b9ccef4bf264e30"/>
   </p:sldLayoutIdLst>
   <p:txStyles>
     <p:titleStyle>
@@ -5738,7 +5753,7 @@
           <a:bodyPr xmlns:a="http://schemas.openxmlformats.org/drawingml/2006/main"/>
           <a:lstStyle xmlns:a="http://schemas.openxmlformats.org/drawingml/2006/main">
             <a:defPPr>
-              <a:defRPr sz="2100" b="0">
+              <a:defRPr sz="1950" b="0">
                 <a:solidFill>
                   <a:srgbClr val="566A80"/>
                 </a:solidFill>
@@ -5850,7 +5865,7 @@
           <a:p xmlns:a="http://schemas.openxmlformats.org/drawingml/2006/main">
             <a:pPr>
               <a:buNone/>
-              <a:defRPr sz="2100" b="0">
+              <a:defRPr sz="1950" b="0">
                 <a:solidFill>
                   <a:srgbClr val="566A80"/>
                 </a:solidFill>
@@ -5860,7 +5875,7 @@
               </a:defRPr>
             </a:pPr>
             <a:r>
-              <a:rPr sz="2100" b="0">
+              <a:rPr sz="1950" b="0">
                 <a:solidFill>
                   <a:srgbClr val="566A80"/>
                 </a:solidFill>
@@ -5868,13 +5883,13 @@
                 <a:ea typeface="Arial"/>
                 <a:cs typeface="Arial"/>
               </a:rPr>
-              <a:t>Рекомендація: виправити pulse та ack за ID,</a:t>
+              <a:t>Виправити pulse та ack за ID, повторити регресію.</a:t>
             </a:r>
           </a:p>
           <a:p xmlns:a="http://schemas.openxmlformats.org/drawingml/2006/main">
             <a:pPr>
               <a:buNone/>
-              <a:defRPr sz="2100" b="0">
+              <a:defRPr sz="1950" b="0">
                 <a:solidFill>
                   <a:srgbClr val="566A80"/>
                 </a:solidFill>
@@ -5884,7 +5899,7 @@
               </a:defRPr>
             </a:pPr>
             <a:r>
-              <a:rPr sz="2100" b="0">
+              <a:rPr sz="1950" b="0">
                 <a:solidFill>
                   <a:srgbClr val="566A80"/>
                 </a:solidFill>
@@ -5892,7 +5907,31 @@
                 <a:ea typeface="Arial"/>
                 <a:cs typeface="Arial"/>
               </a:rPr>
-              <a:t>після цього повторити відповідні перевірки й регресію.</a:t>
+              <a:t>Реле й зовнішній LED: Pass на 2.3.0.</a:t>
+            </a:r>
+          </a:p>
+          <a:p xmlns:a="http://schemas.openxmlformats.org/drawingml/2006/main">
+            <a:pPr>
+              <a:buNone/>
+              <a:defRPr sz="1950" b="0">
+                <a:solidFill>
+                  <a:srgbClr val="566A80"/>
+                </a:solidFill>
+                <a:latin typeface="Arial"/>
+                <a:ea typeface="Arial"/>
+                <a:cs typeface="Arial"/>
+              </a:defRPr>
+            </a:pPr>
+            <a:r>
+              <a:rPr sz="1950" b="0">
+                <a:solidFill>
+                  <a:srgbClr val="566A80"/>
+                </a:solidFill>
+                <a:latin typeface="Arial"/>
+                <a:ea typeface="Arial"/>
+                <a:cs typeface="Arial"/>
+              </a:rPr>
+              <a:t>Кольори RGB та яскравість: Not Run.</a:t>
             </a:r>
           </a:p>
         </p:txBody>
@@ -6999,7 +7038,7 @@
           <p:cNvPr id="8" name="">
             <a:extLst xmlns:a="http://schemas.openxmlformats.org/drawingml/2006/main">
               <a:ext uri="{FF2B5EF4-FFF2-40B4-BE49-F238E27FC236}">
-                <a16:creationId xmlns:a16="http://schemas.microsoft.com/office/drawing/2014/main" id="{9661C429-7953-46D8-BA49-2E63FED7A5B8}"/>
+                <a16:creationId xmlns:a16="http://schemas.microsoft.com/office/drawing/2014/main" id="{7F3DC05D-8E73-4023-8E38-13BF7B897BFB}"/>
               </a:ext>
             </a:extLst>
           </p:cNvPr>
@@ -7009,7 +7048,7 @@
           <p:nvPr/>
         </p:nvPicPr>
         <p:blipFill>
-          <a:blip xmlns:r="http://schemas.openxmlformats.org/officeDocument/2006/relationships" xmlns:a="http://schemas.openxmlformats.org/drawingml/2006/main" r:embed="R5025be20eff74ea1"/>
+          <a:blip xmlns:r="http://schemas.openxmlformats.org/officeDocument/2006/relationships" xmlns:a="http://schemas.openxmlformats.org/drawingml/2006/main" r:embed="R68b108181edf44ca"/>
           <a:stretch xmlns:a="http://schemas.openxmlformats.org/drawingml/2006/main"/>
         </p:blipFill>
         <p:spPr>
@@ -7554,7 +7593,7 @@
           <p:cNvPr id="4" name="">
             <a:extLst xmlns:a="http://schemas.openxmlformats.org/drawingml/2006/main">
               <a:ext uri="{FF2B5EF4-FFF2-40B4-BE49-F238E27FC236}">
-                <a16:creationId xmlns:a16="http://schemas.microsoft.com/office/drawing/2014/main" id="{53689B30-9903-495F-B143-38D8BAE155D6}"/>
+                <a16:creationId xmlns:a16="http://schemas.microsoft.com/office/drawing/2014/main" id="{F139A91F-8E28-41E6-ABA1-0295AFFC8787}"/>
               </a:ext>
             </a:extLst>
           </p:cNvPr>
@@ -10123,6 +10162,7 @@
               </a:defRPr>
             </a:defPPr>
             <a:lvl1pPr>
+              <a:buNone/>
               <a:defRPr sz="3300" b="1">
                 <a:solidFill>
                   <a:srgbClr val="182D45"/>
@@ -10133,6 +10173,7 @@
               </a:defRPr>
             </a:lvl1pPr>
             <a:lvl2pPr>
+              <a:buNone/>
               <a:defRPr sz="3300" b="1">
                 <a:solidFill>
                   <a:srgbClr val="182D45"/>
@@ -10143,6 +10184,7 @@
               </a:defRPr>
             </a:lvl2pPr>
             <a:lvl3pPr>
+              <a:buNone/>
               <a:defRPr sz="3300" b="1">
                 <a:solidFill>
                   <a:srgbClr val="182D45"/>
@@ -10153,6 +10195,7 @@
               </a:defRPr>
             </a:lvl3pPr>
             <a:lvl4pPr>
+              <a:buNone/>
               <a:defRPr sz="3300" b="1">
                 <a:solidFill>
                   <a:srgbClr val="182D45"/>
@@ -10163,6 +10206,7 @@
               </a:defRPr>
             </a:lvl4pPr>
             <a:lvl5pPr>
+              <a:buNone/>
               <a:defRPr sz="3300" b="1">
                 <a:solidFill>
                   <a:srgbClr val="182D45"/>
@@ -10173,6 +10217,7 @@
               </a:defRPr>
             </a:lvl5pPr>
             <a:lvl6pPr>
+              <a:buNone/>
               <a:defRPr sz="3300" b="1">
                 <a:solidFill>
                   <a:srgbClr val="182D45"/>
@@ -10183,6 +10228,7 @@
               </a:defRPr>
             </a:lvl6pPr>
             <a:lvl7pPr>
+              <a:buNone/>
               <a:defRPr sz="3300" b="1">
                 <a:solidFill>
                   <a:srgbClr val="182D45"/>
@@ -10193,6 +10239,7 @@
               </a:defRPr>
             </a:lvl7pPr>
             <a:lvl8pPr>
+              <a:buNone/>
               <a:defRPr sz="3300" b="1">
                 <a:solidFill>
                   <a:srgbClr val="182D45"/>
@@ -10203,6 +10250,7 @@
               </a:defRPr>
             </a:lvl8pPr>
             <a:lvl9pPr>
+              <a:buNone/>
               <a:defRPr sz="3300" b="1">
                 <a:solidFill>
                   <a:srgbClr val="182D45"/>
@@ -10215,6 +10263,7 @@
           </a:lstStyle>
           <a:p xmlns:a="http://schemas.openxmlformats.org/drawingml/2006/main">
             <a:pPr>
+              <a:buNone/>
               <a:defRPr sz="3300" b="1">
                 <a:solidFill>
                   <a:srgbClr val="182D45"/>
@@ -10243,7 +10292,7 @@
           <p:cNvPr id="2" name="">
             <a:extLst xmlns:a="http://schemas.openxmlformats.org/drawingml/2006/main">
               <a:ext uri="{FF2B5EF4-FFF2-40B4-BE49-F238E27FC236}">
-                <a16:creationId xmlns:a16="http://schemas.microsoft.com/office/drawing/2014/main" id="{DED0CDF1-601D-44E6-BE6B-6339124FA956}"/>
+                <a16:creationId xmlns:a16="http://schemas.microsoft.com/office/drawing/2014/main" id="{ADE7CB45-3180-4B77-A2FF-3947EAA4ABD4}"/>
               </a:ext>
             </a:extLst>
           </p:cNvPr>
@@ -10253,7 +10302,7 @@
           <p:nvPr/>
         </p:nvPicPr>
         <p:blipFill>
-          <a:blip xmlns:r="http://schemas.openxmlformats.org/officeDocument/2006/relationships" xmlns:a="http://schemas.openxmlformats.org/drawingml/2006/main" r:embed="R20095fbb25524d53"/>
+          <a:blip xmlns:r="http://schemas.openxmlformats.org/officeDocument/2006/relationships" xmlns:a="http://schemas.openxmlformats.org/drawingml/2006/main" r:embed="R470e512c81d84189"/>
           <a:stretch xmlns:a="http://schemas.openxmlformats.org/drawingml/2006/main"/>
         </p:blipFill>
         <p:spPr>
@@ -10307,6 +10356,7 @@
               </a:defRPr>
             </a:defPPr>
             <a:lvl1pPr>
+              <a:buNone/>
               <a:defRPr sz="2400" b="1">
                 <a:solidFill>
                   <a:srgbClr val="087F8C"/>
@@ -10317,6 +10367,7 @@
               </a:defRPr>
             </a:lvl1pPr>
             <a:lvl2pPr>
+              <a:buNone/>
               <a:defRPr sz="2400" b="1">
                 <a:solidFill>
                   <a:srgbClr val="087F8C"/>
@@ -10327,6 +10378,7 @@
               </a:defRPr>
             </a:lvl2pPr>
             <a:lvl3pPr>
+              <a:buNone/>
               <a:defRPr sz="2400" b="1">
                 <a:solidFill>
                   <a:srgbClr val="087F8C"/>
@@ -10337,6 +10389,7 @@
               </a:defRPr>
             </a:lvl3pPr>
             <a:lvl4pPr>
+              <a:buNone/>
               <a:defRPr sz="2400" b="1">
                 <a:solidFill>
                   <a:srgbClr val="087F8C"/>
@@ -10347,6 +10400,7 @@
               </a:defRPr>
             </a:lvl4pPr>
             <a:lvl5pPr>
+              <a:buNone/>
               <a:defRPr sz="2400" b="1">
                 <a:solidFill>
                   <a:srgbClr val="087F8C"/>
@@ -10357,6 +10411,7 @@
               </a:defRPr>
             </a:lvl5pPr>
             <a:lvl6pPr>
+              <a:buNone/>
               <a:defRPr sz="2400" b="1">
                 <a:solidFill>
                   <a:srgbClr val="087F8C"/>
@@ -10367,6 +10422,7 @@
               </a:defRPr>
             </a:lvl6pPr>
             <a:lvl7pPr>
+              <a:buNone/>
               <a:defRPr sz="2400" b="1">
                 <a:solidFill>
                   <a:srgbClr val="087F8C"/>
@@ -10377,6 +10433,7 @@
               </a:defRPr>
             </a:lvl7pPr>
             <a:lvl8pPr>
+              <a:buNone/>
               <a:defRPr sz="2400" b="1">
                 <a:solidFill>
                   <a:srgbClr val="087F8C"/>
@@ -10387,6 +10444,7 @@
               </a:defRPr>
             </a:lvl8pPr>
             <a:lvl9pPr>
+              <a:buNone/>
               <a:defRPr sz="2400" b="1">
                 <a:solidFill>
                   <a:srgbClr val="087F8C"/>
@@ -10399,6 +10457,7 @@
           </a:lstStyle>
           <a:p xmlns:a="http://schemas.openxmlformats.org/drawingml/2006/main">
             <a:pPr>
+              <a:buNone/>
               <a:defRPr sz="2400" b="1">
                 <a:solidFill>
                   <a:srgbClr val="087F8C"/>
@@ -10463,6 +10522,7 @@
               </a:defRPr>
             </a:defPPr>
             <a:lvl1pPr>
+              <a:buNone/>
               <a:defRPr sz="2025" b="0">
                 <a:solidFill>
                   <a:srgbClr val="182D45"/>
@@ -10473,6 +10533,7 @@
               </a:defRPr>
             </a:lvl1pPr>
             <a:lvl2pPr>
+              <a:buNone/>
               <a:defRPr sz="2025" b="0">
                 <a:solidFill>
                   <a:srgbClr val="182D45"/>
@@ -10483,6 +10544,7 @@
               </a:defRPr>
             </a:lvl2pPr>
             <a:lvl3pPr>
+              <a:buNone/>
               <a:defRPr sz="2025" b="0">
                 <a:solidFill>
                   <a:srgbClr val="182D45"/>
@@ -10493,6 +10555,7 @@
               </a:defRPr>
             </a:lvl3pPr>
             <a:lvl4pPr>
+              <a:buNone/>
               <a:defRPr sz="2025" b="0">
                 <a:solidFill>
                   <a:srgbClr val="182D45"/>
@@ -10503,6 +10566,7 @@
               </a:defRPr>
             </a:lvl4pPr>
             <a:lvl5pPr>
+              <a:buNone/>
               <a:defRPr sz="2025" b="0">
                 <a:solidFill>
                   <a:srgbClr val="182D45"/>
@@ -10513,6 +10577,7 @@
               </a:defRPr>
             </a:lvl5pPr>
             <a:lvl6pPr>
+              <a:buNone/>
               <a:defRPr sz="2025" b="0">
                 <a:solidFill>
                   <a:srgbClr val="182D45"/>
@@ -10523,6 +10588,7 @@
               </a:defRPr>
             </a:lvl6pPr>
             <a:lvl7pPr>
+              <a:buNone/>
               <a:defRPr sz="2025" b="0">
                 <a:solidFill>
                   <a:srgbClr val="182D45"/>
@@ -10533,6 +10599,7 @@
               </a:defRPr>
             </a:lvl7pPr>
             <a:lvl8pPr>
+              <a:buNone/>
               <a:defRPr sz="2025" b="0">
                 <a:solidFill>
                   <a:srgbClr val="182D45"/>
@@ -10543,6 +10610,7 @@
               </a:defRPr>
             </a:lvl8pPr>
             <a:lvl9pPr>
+              <a:buNone/>
               <a:defRPr sz="2025" b="0">
                 <a:solidFill>
                   <a:srgbClr val="182D45"/>
@@ -10555,6 +10623,7 @@
           </a:lstStyle>
           <a:p xmlns:a="http://schemas.openxmlformats.org/drawingml/2006/main">
             <a:pPr>
+              <a:buNone/>
               <a:defRPr sz="2025" b="0">
                 <a:solidFill>
                   <a:srgbClr val="182D45"/>
@@ -10619,6 +10688,7 @@
               </a:defRPr>
             </a:defPPr>
             <a:lvl1pPr>
+              <a:buNone/>
               <a:defRPr sz="2250" b="1">
                 <a:solidFill>
                   <a:srgbClr val="182D45"/>
@@ -10629,6 +10699,7 @@
               </a:defRPr>
             </a:lvl1pPr>
             <a:lvl2pPr>
+              <a:buNone/>
               <a:defRPr sz="2250" b="1">
                 <a:solidFill>
                   <a:srgbClr val="182D45"/>
@@ -10639,6 +10710,7 @@
               </a:defRPr>
             </a:lvl2pPr>
             <a:lvl3pPr>
+              <a:buNone/>
               <a:defRPr sz="2250" b="1">
                 <a:solidFill>
                   <a:srgbClr val="182D45"/>
@@ -10649,6 +10721,7 @@
               </a:defRPr>
             </a:lvl3pPr>
             <a:lvl4pPr>
+              <a:buNone/>
               <a:defRPr sz="2250" b="1">
                 <a:solidFill>
                   <a:srgbClr val="182D45"/>
@@ -10659,6 +10732,7 @@
               </a:defRPr>
             </a:lvl4pPr>
             <a:lvl5pPr>
+              <a:buNone/>
               <a:defRPr sz="2250" b="1">
                 <a:solidFill>
                   <a:srgbClr val="182D45"/>
@@ -10669,6 +10743,7 @@
               </a:defRPr>
             </a:lvl5pPr>
             <a:lvl6pPr>
+              <a:buNone/>
               <a:defRPr sz="2250" b="1">
                 <a:solidFill>
                   <a:srgbClr val="182D45"/>
@@ -10679,6 +10754,7 @@
               </a:defRPr>
             </a:lvl6pPr>
             <a:lvl7pPr>
+              <a:buNone/>
               <a:defRPr sz="2250" b="1">
                 <a:solidFill>
                   <a:srgbClr val="182D45"/>
@@ -10689,6 +10765,7 @@
               </a:defRPr>
             </a:lvl7pPr>
             <a:lvl8pPr>
+              <a:buNone/>
               <a:defRPr sz="2250" b="1">
                 <a:solidFill>
                   <a:srgbClr val="182D45"/>
@@ -10699,6 +10776,7 @@
               </a:defRPr>
             </a:lvl8pPr>
             <a:lvl9pPr>
+              <a:buNone/>
               <a:defRPr sz="2250" b="1">
                 <a:solidFill>
                   <a:srgbClr val="182D45"/>
@@ -10711,6 +10789,7 @@
           </a:lstStyle>
           <a:p xmlns:a="http://schemas.openxmlformats.org/drawingml/2006/main">
             <a:pPr>
+              <a:buNone/>
               <a:defRPr sz="2250" b="1">
                 <a:solidFill>
                   <a:srgbClr val="182D45"/>
@@ -10775,6 +10854,7 @@
               </a:defRPr>
             </a:defPPr>
             <a:lvl1pPr>
+              <a:buNone/>
               <a:defRPr sz="1950" b="0">
                 <a:solidFill>
                   <a:srgbClr val="182D45"/>
@@ -10785,6 +10865,7 @@
               </a:defRPr>
             </a:lvl1pPr>
             <a:lvl2pPr>
+              <a:buNone/>
               <a:defRPr sz="1950" b="0">
                 <a:solidFill>
                   <a:srgbClr val="182D45"/>
@@ -10795,6 +10876,7 @@
               </a:defRPr>
             </a:lvl2pPr>
             <a:lvl3pPr>
+              <a:buNone/>
               <a:defRPr sz="1950" b="0">
                 <a:solidFill>
                   <a:srgbClr val="182D45"/>
@@ -10805,6 +10887,7 @@
               </a:defRPr>
             </a:lvl3pPr>
             <a:lvl4pPr>
+              <a:buNone/>
               <a:defRPr sz="1950" b="0">
                 <a:solidFill>
                   <a:srgbClr val="182D45"/>
@@ -10815,6 +10898,7 @@
               </a:defRPr>
             </a:lvl4pPr>
             <a:lvl5pPr>
+              <a:buNone/>
               <a:defRPr sz="1950" b="0">
                 <a:solidFill>
                   <a:srgbClr val="182D45"/>
@@ -10825,6 +10909,7 @@
               </a:defRPr>
             </a:lvl5pPr>
             <a:lvl6pPr>
+              <a:buNone/>
               <a:defRPr sz="1950" b="0">
                 <a:solidFill>
                   <a:srgbClr val="182D45"/>
@@ -10835,6 +10920,7 @@
               </a:defRPr>
             </a:lvl6pPr>
             <a:lvl7pPr>
+              <a:buNone/>
               <a:defRPr sz="1950" b="0">
                 <a:solidFill>
                   <a:srgbClr val="182D45"/>
@@ -10845,6 +10931,7 @@
               </a:defRPr>
             </a:lvl7pPr>
             <a:lvl8pPr>
+              <a:buNone/>
               <a:defRPr sz="1950" b="0">
                 <a:solidFill>
                   <a:srgbClr val="182D45"/>
@@ -10855,6 +10942,7 @@
               </a:defRPr>
             </a:lvl8pPr>
             <a:lvl9pPr>
+              <a:buNone/>
               <a:defRPr sz="1950" b="0">
                 <a:solidFill>
                   <a:srgbClr val="182D45"/>
@@ -10867,6 +10955,7 @@
           </a:lstStyle>
           <a:p xmlns:a="http://schemas.openxmlformats.org/drawingml/2006/main">
             <a:pPr>
+              <a:buNone/>
               <a:defRPr sz="1950" b="0">
                 <a:solidFill>
                   <a:srgbClr val="182D45"/>
@@ -10931,6 +11020,7 @@
               </a:defRPr>
             </a:defPPr>
             <a:lvl1pPr>
+              <a:buNone/>
               <a:defRPr sz="2250" b="1">
                 <a:solidFill>
                   <a:srgbClr val="182D45"/>
@@ -10941,6 +11031,7 @@
               </a:defRPr>
             </a:lvl1pPr>
             <a:lvl2pPr>
+              <a:buNone/>
               <a:defRPr sz="2250" b="1">
                 <a:solidFill>
                   <a:srgbClr val="182D45"/>
@@ -10951,6 +11042,7 @@
               </a:defRPr>
             </a:lvl2pPr>
             <a:lvl3pPr>
+              <a:buNone/>
               <a:defRPr sz="2250" b="1">
                 <a:solidFill>
                   <a:srgbClr val="182D45"/>
@@ -10961,6 +11053,7 @@
               </a:defRPr>
             </a:lvl3pPr>
             <a:lvl4pPr>
+              <a:buNone/>
               <a:defRPr sz="2250" b="1">
                 <a:solidFill>
                   <a:srgbClr val="182D45"/>
@@ -10971,6 +11064,7 @@
               </a:defRPr>
             </a:lvl4pPr>
             <a:lvl5pPr>
+              <a:buNone/>
               <a:defRPr sz="2250" b="1">
                 <a:solidFill>
                   <a:srgbClr val="182D45"/>
@@ -10981,6 +11075,7 @@
               </a:defRPr>
             </a:lvl5pPr>
             <a:lvl6pPr>
+              <a:buNone/>
               <a:defRPr sz="2250" b="1">
                 <a:solidFill>
                   <a:srgbClr val="182D45"/>
@@ -10991,6 +11086,7 @@
               </a:defRPr>
             </a:lvl6pPr>
             <a:lvl7pPr>
+              <a:buNone/>
               <a:defRPr sz="2250" b="1">
                 <a:solidFill>
                   <a:srgbClr val="182D45"/>
@@ -11001,6 +11097,7 @@
               </a:defRPr>
             </a:lvl7pPr>
             <a:lvl8pPr>
+              <a:buNone/>
               <a:defRPr sz="2250" b="1">
                 <a:solidFill>
                   <a:srgbClr val="182D45"/>
@@ -11011,6 +11108,7 @@
               </a:defRPr>
             </a:lvl8pPr>
             <a:lvl9pPr>
+              <a:buNone/>
               <a:defRPr sz="2250" b="1">
                 <a:solidFill>
                   <a:srgbClr val="182D45"/>
@@ -11023,6 +11121,7 @@
           </a:lstStyle>
           <a:p xmlns:a="http://schemas.openxmlformats.org/drawingml/2006/main">
             <a:pPr>
+              <a:buNone/>
               <a:defRPr sz="2250" b="1">
                 <a:solidFill>
                   <a:srgbClr val="182D45"/>
@@ -11087,6 +11186,7 @@
               </a:defRPr>
             </a:defPPr>
             <a:lvl1pPr>
+              <a:buNone/>
               <a:defRPr sz="2025" b="0">
                 <a:solidFill>
                   <a:srgbClr val="182D45"/>
@@ -11097,6 +11197,7 @@
               </a:defRPr>
             </a:lvl1pPr>
             <a:lvl2pPr>
+              <a:buNone/>
               <a:defRPr sz="2025" b="0">
                 <a:solidFill>
                   <a:srgbClr val="182D45"/>
@@ -11107,6 +11208,7 @@
               </a:defRPr>
             </a:lvl2pPr>
             <a:lvl3pPr>
+              <a:buNone/>
               <a:defRPr sz="2025" b="0">
                 <a:solidFill>
                   <a:srgbClr val="182D45"/>
@@ -11117,6 +11219,7 @@
               </a:defRPr>
             </a:lvl3pPr>
             <a:lvl4pPr>
+              <a:buNone/>
               <a:defRPr sz="2025" b="0">
                 <a:solidFill>
                   <a:srgbClr val="182D45"/>
@@ -11127,6 +11230,7 @@
               </a:defRPr>
             </a:lvl4pPr>
             <a:lvl5pPr>
+              <a:buNone/>
               <a:defRPr sz="2025" b="0">
                 <a:solidFill>
                   <a:srgbClr val="182D45"/>
@@ -11137,6 +11241,7 @@
               </a:defRPr>
             </a:lvl5pPr>
             <a:lvl6pPr>
+              <a:buNone/>
               <a:defRPr sz="2025" b="0">
                 <a:solidFill>
                   <a:srgbClr val="182D45"/>
@@ -11147,6 +11252,7 @@
               </a:defRPr>
             </a:lvl6pPr>
             <a:lvl7pPr>
+              <a:buNone/>
               <a:defRPr sz="2025" b="0">
                 <a:solidFill>
                   <a:srgbClr val="182D45"/>
@@ -11157,6 +11263,7 @@
               </a:defRPr>
             </a:lvl7pPr>
             <a:lvl8pPr>
+              <a:buNone/>
               <a:defRPr sz="2025" b="0">
                 <a:solidFill>
                   <a:srgbClr val="182D45"/>
@@ -11167,6 +11274,7 @@
               </a:defRPr>
             </a:lvl8pPr>
             <a:lvl9pPr>
+              <a:buNone/>
               <a:defRPr sz="2025" b="0">
                 <a:solidFill>
                   <a:srgbClr val="182D45"/>
@@ -11179,6 +11287,7 @@
           </a:lstStyle>
           <a:p xmlns:a="http://schemas.openxmlformats.org/drawingml/2006/main">
             <a:pPr>
+              <a:buNone/>
               <a:defRPr sz="2025" b="0">
                 <a:solidFill>
                   <a:srgbClr val="182D45"/>
@@ -11243,6 +11352,7 @@
               </a:defRPr>
             </a:defPPr>
             <a:lvl1pPr>
+              <a:buNone/>
               <a:defRPr sz="2250" b="1">
                 <a:solidFill>
                   <a:srgbClr val="182D45"/>
@@ -11253,6 +11363,7 @@
               </a:defRPr>
             </a:lvl1pPr>
             <a:lvl2pPr>
+              <a:buNone/>
               <a:defRPr sz="2250" b="1">
                 <a:solidFill>
                   <a:srgbClr val="182D45"/>
@@ -11263,6 +11374,7 @@
               </a:defRPr>
             </a:lvl2pPr>
             <a:lvl3pPr>
+              <a:buNone/>
               <a:defRPr sz="2250" b="1">
                 <a:solidFill>
                   <a:srgbClr val="182D45"/>
@@ -11273,6 +11385,7 @@
               </a:defRPr>
             </a:lvl3pPr>
             <a:lvl4pPr>
+              <a:buNone/>
               <a:defRPr sz="2250" b="1">
                 <a:solidFill>
                   <a:srgbClr val="182D45"/>
@@ -11283,6 +11396,7 @@
               </a:defRPr>
             </a:lvl4pPr>
             <a:lvl5pPr>
+              <a:buNone/>
               <a:defRPr sz="2250" b="1">
                 <a:solidFill>
                   <a:srgbClr val="182D45"/>
@@ -11293,6 +11407,7 @@
               </a:defRPr>
             </a:lvl5pPr>
             <a:lvl6pPr>
+              <a:buNone/>
               <a:defRPr sz="2250" b="1">
                 <a:solidFill>
                   <a:srgbClr val="182D45"/>
@@ -11303,6 +11418,7 @@
               </a:defRPr>
             </a:lvl6pPr>
             <a:lvl7pPr>
+              <a:buNone/>
               <a:defRPr sz="2250" b="1">
                 <a:solidFill>
                   <a:srgbClr val="182D45"/>
@@ -11313,6 +11429,7 @@
               </a:defRPr>
             </a:lvl7pPr>
             <a:lvl8pPr>
+              <a:buNone/>
               <a:defRPr sz="2250" b="1">
                 <a:solidFill>
                   <a:srgbClr val="182D45"/>
@@ -11323,6 +11440,7 @@
               </a:defRPr>
             </a:lvl8pPr>
             <a:lvl9pPr>
+              <a:buNone/>
               <a:defRPr sz="2250" b="1">
                 <a:solidFill>
                   <a:srgbClr val="182D45"/>
@@ -11335,6 +11453,7 @@
           </a:lstStyle>
           <a:p xmlns:a="http://schemas.openxmlformats.org/drawingml/2006/main">
             <a:pPr>
+              <a:buNone/>
               <a:defRPr sz="2250" b="1">
                 <a:solidFill>
                   <a:srgbClr val="182D45"/>
@@ -11399,6 +11518,7 @@
               </a:defRPr>
             </a:defPPr>
             <a:lvl1pPr>
+              <a:buNone/>
               <a:defRPr sz="2025" b="0">
                 <a:solidFill>
                   <a:srgbClr val="182D45"/>
@@ -11409,6 +11529,7 @@
               </a:defRPr>
             </a:lvl1pPr>
             <a:lvl2pPr>
+              <a:buNone/>
               <a:defRPr sz="2025" b="0">
                 <a:solidFill>
                   <a:srgbClr val="182D45"/>
@@ -11419,6 +11540,7 @@
               </a:defRPr>
             </a:lvl2pPr>
             <a:lvl3pPr>
+              <a:buNone/>
               <a:defRPr sz="2025" b="0">
                 <a:solidFill>
                   <a:srgbClr val="182D45"/>
@@ -11429,6 +11551,7 @@
               </a:defRPr>
             </a:lvl3pPr>
             <a:lvl4pPr>
+              <a:buNone/>
               <a:defRPr sz="2025" b="0">
                 <a:solidFill>
                   <a:srgbClr val="182D45"/>
@@ -11439,6 +11562,7 @@
               </a:defRPr>
             </a:lvl4pPr>
             <a:lvl5pPr>
+              <a:buNone/>
               <a:defRPr sz="2025" b="0">
                 <a:solidFill>
                   <a:srgbClr val="182D45"/>
@@ -11449,6 +11573,7 @@
               </a:defRPr>
             </a:lvl5pPr>
             <a:lvl6pPr>
+              <a:buNone/>
               <a:defRPr sz="2025" b="0">
                 <a:solidFill>
                   <a:srgbClr val="182D45"/>
@@ -11459,6 +11584,7 @@
               </a:defRPr>
             </a:lvl6pPr>
             <a:lvl7pPr>
+              <a:buNone/>
               <a:defRPr sz="2025" b="0">
                 <a:solidFill>
                   <a:srgbClr val="182D45"/>
@@ -11469,6 +11595,7 @@
               </a:defRPr>
             </a:lvl7pPr>
             <a:lvl8pPr>
+              <a:buNone/>
               <a:defRPr sz="2025" b="0">
                 <a:solidFill>
                   <a:srgbClr val="182D45"/>
@@ -11479,6 +11606,7 @@
               </a:defRPr>
             </a:lvl8pPr>
             <a:lvl9pPr>
+              <a:buNone/>
               <a:defRPr sz="2025" b="0">
                 <a:solidFill>
                   <a:srgbClr val="182D45"/>
@@ -11491,6 +11619,7 @@
           </a:lstStyle>
           <a:p xmlns:a="http://schemas.openxmlformats.org/drawingml/2006/main">
             <a:pPr>
+              <a:buNone/>
               <a:defRPr sz="2025" b="0">
                 <a:solidFill>
                   <a:srgbClr val="182D45"/>
@@ -11555,6 +11684,7 @@
               </a:defRPr>
             </a:defPPr>
             <a:lvl1pPr>
+              <a:buNone/>
               <a:defRPr sz="1650" b="0">
                 <a:solidFill>
                   <a:srgbClr val="566A80"/>
@@ -11565,6 +11695,7 @@
               </a:defRPr>
             </a:lvl1pPr>
             <a:lvl2pPr>
+              <a:buNone/>
               <a:defRPr sz="1650" b="0">
                 <a:solidFill>
                   <a:srgbClr val="566A80"/>
@@ -11575,6 +11706,7 @@
               </a:defRPr>
             </a:lvl2pPr>
             <a:lvl3pPr>
+              <a:buNone/>
               <a:defRPr sz="1650" b="0">
                 <a:solidFill>
                   <a:srgbClr val="566A80"/>
@@ -11585,6 +11717,7 @@
               </a:defRPr>
             </a:lvl3pPr>
             <a:lvl4pPr>
+              <a:buNone/>
               <a:defRPr sz="1650" b="0">
                 <a:solidFill>
                   <a:srgbClr val="566A80"/>
@@ -11595,6 +11728,7 @@
               </a:defRPr>
             </a:lvl4pPr>
             <a:lvl5pPr>
+              <a:buNone/>
               <a:defRPr sz="1650" b="0">
                 <a:solidFill>
                   <a:srgbClr val="566A80"/>
@@ -11605,6 +11739,7 @@
               </a:defRPr>
             </a:lvl5pPr>
             <a:lvl6pPr>
+              <a:buNone/>
               <a:defRPr sz="1650" b="0">
                 <a:solidFill>
                   <a:srgbClr val="566A80"/>
@@ -11615,6 +11750,7 @@
               </a:defRPr>
             </a:lvl6pPr>
             <a:lvl7pPr>
+              <a:buNone/>
               <a:defRPr sz="1650" b="0">
                 <a:solidFill>
                   <a:srgbClr val="566A80"/>
@@ -11625,6 +11761,7 @@
               </a:defRPr>
             </a:lvl7pPr>
             <a:lvl8pPr>
+              <a:buNone/>
               <a:defRPr sz="1650" b="0">
                 <a:solidFill>
                   <a:srgbClr val="566A80"/>
@@ -11635,6 +11772,7 @@
               </a:defRPr>
             </a:lvl8pPr>
             <a:lvl9pPr>
+              <a:buNone/>
               <a:defRPr sz="1650" b="0">
                 <a:solidFill>
                   <a:srgbClr val="566A80"/>
@@ -11647,6 +11785,7 @@
           </a:lstStyle>
           <a:p xmlns:a="http://schemas.openxmlformats.org/drawingml/2006/main">
             <a:pPr>
+              <a:buNone/>
               <a:defRPr sz="1650" b="0">
                 <a:solidFill>
                   <a:srgbClr val="566A80"/>
@@ -11665,11 +11804,12 @@
                 <a:ea typeface="Arial"/>
                 <a:cs typeface="Arial"/>
               </a:rPr>
-              <a:t>Фото стенда від 24.10.2026. Результати</a:t>
+              <a:t>2.3.0: реле та зовнішній LED — Pass.</a:t>
             </a:r>
           </a:p>
           <a:p xmlns:a="http://schemas.openxmlformats.org/drawingml/2006/main">
             <a:pPr>
+              <a:buNone/>
               <a:defRPr sz="1650" b="0">
                 <a:solidFill>
                   <a:srgbClr val="566A80"/>
@@ -11688,7 +11828,7 @@
                 <a:ea typeface="Arial"/>
                 <a:cs typeface="Arial"/>
               </a:rPr>
-              <a:t>фізичних перевірок фіксуються в журналі.</a:t>
+              <a:t>Підтверджено виконавцем 24.10.2026.</a:t>
             </a:r>
           </a:p>
         </p:txBody>
@@ -11734,6 +11874,7 @@
               </a:defRPr>
             </a:defPPr>
             <a:lvl1pPr>
+              <a:buNone/>
               <a:defRPr sz="1350" b="0">
                 <a:solidFill>
                   <a:srgbClr val="566A80"/>
@@ -11744,6 +11885,7 @@
               </a:defRPr>
             </a:lvl1pPr>
             <a:lvl2pPr>
+              <a:buNone/>
               <a:defRPr sz="1350" b="0">
                 <a:solidFill>
                   <a:srgbClr val="566A80"/>
@@ -11754,6 +11896,7 @@
               </a:defRPr>
             </a:lvl2pPr>
             <a:lvl3pPr>
+              <a:buNone/>
               <a:defRPr sz="1350" b="0">
                 <a:solidFill>
                   <a:srgbClr val="566A80"/>
@@ -11764,6 +11907,7 @@
               </a:defRPr>
             </a:lvl3pPr>
             <a:lvl4pPr>
+              <a:buNone/>
               <a:defRPr sz="1350" b="0">
                 <a:solidFill>
                   <a:srgbClr val="566A80"/>
@@ -11774,6 +11918,7 @@
               </a:defRPr>
             </a:lvl4pPr>
             <a:lvl5pPr>
+              <a:buNone/>
               <a:defRPr sz="1350" b="0">
                 <a:solidFill>
                   <a:srgbClr val="566A80"/>
@@ -11784,6 +11929,7 @@
               </a:defRPr>
             </a:lvl5pPr>
             <a:lvl6pPr>
+              <a:buNone/>
               <a:defRPr sz="1350" b="0">
                 <a:solidFill>
                   <a:srgbClr val="566A80"/>
@@ -11794,6 +11940,7 @@
               </a:defRPr>
             </a:lvl6pPr>
             <a:lvl7pPr>
+              <a:buNone/>
               <a:defRPr sz="1350" b="0">
                 <a:solidFill>
                   <a:srgbClr val="566A80"/>
@@ -11804,6 +11951,7 @@
               </a:defRPr>
             </a:lvl7pPr>
             <a:lvl8pPr>
+              <a:buNone/>
               <a:defRPr sz="1350" b="0">
                 <a:solidFill>
                   <a:srgbClr val="566A80"/>
@@ -11814,6 +11962,7 @@
               </a:defRPr>
             </a:lvl8pPr>
             <a:lvl9pPr>
+              <a:buNone/>
               <a:defRPr sz="1350" b="0">
                 <a:solidFill>
                   <a:srgbClr val="566A80"/>
@@ -11826,6 +11975,7 @@
           </a:lstStyle>
           <a:p xmlns:a="http://schemas.openxmlformats.org/drawingml/2006/main">
             <a:pPr>
+              <a:buNone/>
               <a:defRPr sz="1350" b="0">
                 <a:solidFill>
                   <a:srgbClr val="566A80"/>
@@ -12215,7 +12365,7 @@
           <p:cNvPr id="4" name="">
             <a:extLst xmlns:a="http://schemas.openxmlformats.org/drawingml/2006/main">
               <a:ext uri="{FF2B5EF4-FFF2-40B4-BE49-F238E27FC236}">
-                <a16:creationId xmlns:a16="http://schemas.microsoft.com/office/drawing/2014/main" id="{9AF2877B-250F-4D7D-8CE0-598DA2D7D333}"/>
+                <a16:creationId xmlns:a16="http://schemas.microsoft.com/office/drawing/2014/main" id="{F2E2F041-8D30-4C5A-874E-F0AC3F21F978}"/>
               </a:ext>
             </a:extLst>
           </p:cNvPr>
@@ -13443,7 +13593,7 @@
           <p:cNvPr id="4" name="">
             <a:extLst xmlns:a="http://schemas.openxmlformats.org/drawingml/2006/main">
               <a:ext uri="{FF2B5EF4-FFF2-40B4-BE49-F238E27FC236}">
-                <a16:creationId xmlns:a16="http://schemas.microsoft.com/office/drawing/2014/main" id="{CAB24C05-287E-41AC-A2B1-C4AE15ED731D}"/>
+                <a16:creationId xmlns:a16="http://schemas.microsoft.com/office/drawing/2014/main" id="{F199FFCD-5E78-45A4-A50E-ED7155A0A86D}"/>
               </a:ext>
             </a:extLst>
           </p:cNvPr>
@@ -14415,6 +14565,162 @@
                 <a:cs typeface="Arial"/>
               </a:rPr>
               <a:t>Повторні відтворення не збільшують підсумок основних прогонів.</a:t>
+            </a:r>
+          </a:p>
+        </p:txBody>
+      </p:sp>
+      <p:sp>
+        <p:nvSpPr>
+          <p:cNvPr id="7" name="manual-results">
+            <a:extLst xmlns:a="http://schemas.openxmlformats.org/drawingml/2006/main">
+              <a:ext uri="{FF2B5EF4-FFF2-40B4-BE49-F238E27FC236}">
+                <a16:creationId xmlns:a16="http://schemas.microsoft.com/office/drawing/2014/main" id="{5DFB1954-8272-4CD3-A305-129B02B5AA45}"/>
+              </a:ext>
+            </a:extLst>
+          </p:cNvPr>
+          <p:cNvSpPr>
+            <a:spLocks xmlns:a="http://schemas.openxmlformats.org/drawingml/2006/main" noGrp="1"/>
+          </p:cNvSpPr>
+          <p:nvPr/>
+        </p:nvSpPr>
+        <p:spPr>
+          <a:xfrm xmlns:a="http://schemas.openxmlformats.org/drawingml/2006/main">
+            <a:off x="609600" y="5953125"/>
+            <a:ext cx="10972800" cy="361950"/>
+          </a:xfrm>
+          <a:prstGeom xmlns:a="http://schemas.openxmlformats.org/drawingml/2006/main" prst="rect">
+            <a:avLst/>
+          </a:prstGeom>
+          <a:noFill xmlns:a="http://schemas.openxmlformats.org/drawingml/2006/main"/>
+          <a:ln xmlns:a="http://schemas.openxmlformats.org/drawingml/2006/main" w="0">
+            <a:noFill/>
+          </a:ln>
+        </p:spPr>
+        <p:txBody>
+          <a:bodyPr xmlns:a="http://schemas.openxmlformats.org/drawingml/2006/main"/>
+          <a:lstStyle xmlns:a="http://schemas.openxmlformats.org/drawingml/2006/main">
+            <a:defPPr>
+              <a:defRPr sz="1950" b="1">
+                <a:solidFill>
+                  <a:srgbClr val="087F8C"/>
+                </a:solidFill>
+                <a:latin typeface="Arial"/>
+                <a:ea typeface="Arial"/>
+                <a:cs typeface="Arial"/>
+              </a:defRPr>
+            </a:defPPr>
+            <a:lvl1pPr>
+              <a:defRPr sz="1950" b="1">
+                <a:solidFill>
+                  <a:srgbClr val="087F8C"/>
+                </a:solidFill>
+                <a:latin typeface="Arial"/>
+                <a:ea typeface="Arial"/>
+                <a:cs typeface="Arial"/>
+              </a:defRPr>
+            </a:lvl1pPr>
+            <a:lvl2pPr>
+              <a:defRPr sz="1950" b="1">
+                <a:solidFill>
+                  <a:srgbClr val="087F8C"/>
+                </a:solidFill>
+                <a:latin typeface="Arial"/>
+                <a:ea typeface="Arial"/>
+                <a:cs typeface="Arial"/>
+              </a:defRPr>
+            </a:lvl2pPr>
+            <a:lvl3pPr>
+              <a:defRPr sz="1950" b="1">
+                <a:solidFill>
+                  <a:srgbClr val="087F8C"/>
+                </a:solidFill>
+                <a:latin typeface="Arial"/>
+                <a:ea typeface="Arial"/>
+                <a:cs typeface="Arial"/>
+              </a:defRPr>
+            </a:lvl3pPr>
+            <a:lvl4pPr>
+              <a:defRPr sz="1950" b="1">
+                <a:solidFill>
+                  <a:srgbClr val="087F8C"/>
+                </a:solidFill>
+                <a:latin typeface="Arial"/>
+                <a:ea typeface="Arial"/>
+                <a:cs typeface="Arial"/>
+              </a:defRPr>
+            </a:lvl4pPr>
+            <a:lvl5pPr>
+              <a:defRPr sz="1950" b="1">
+                <a:solidFill>
+                  <a:srgbClr val="087F8C"/>
+                </a:solidFill>
+                <a:latin typeface="Arial"/>
+                <a:ea typeface="Arial"/>
+                <a:cs typeface="Arial"/>
+              </a:defRPr>
+            </a:lvl5pPr>
+            <a:lvl6pPr>
+              <a:defRPr sz="1950" b="1">
+                <a:solidFill>
+                  <a:srgbClr val="087F8C"/>
+                </a:solidFill>
+                <a:latin typeface="Arial"/>
+                <a:ea typeface="Arial"/>
+                <a:cs typeface="Arial"/>
+              </a:defRPr>
+            </a:lvl6pPr>
+            <a:lvl7pPr>
+              <a:defRPr sz="1950" b="1">
+                <a:solidFill>
+                  <a:srgbClr val="087F8C"/>
+                </a:solidFill>
+                <a:latin typeface="Arial"/>
+                <a:ea typeface="Arial"/>
+                <a:cs typeface="Arial"/>
+              </a:defRPr>
+            </a:lvl7pPr>
+            <a:lvl8pPr>
+              <a:defRPr sz="1950" b="1">
+                <a:solidFill>
+                  <a:srgbClr val="087F8C"/>
+                </a:solidFill>
+                <a:latin typeface="Arial"/>
+                <a:ea typeface="Arial"/>
+                <a:cs typeface="Arial"/>
+              </a:defRPr>
+            </a:lvl8pPr>
+            <a:lvl9pPr>
+              <a:defRPr sz="1950" b="1">
+                <a:solidFill>
+                  <a:srgbClr val="087F8C"/>
+                </a:solidFill>
+                <a:latin typeface="Arial"/>
+                <a:ea typeface="Arial"/>
+                <a:cs typeface="Arial"/>
+              </a:defRPr>
+            </a:lvl9pPr>
+          </a:lstStyle>
+          <a:p xmlns:a="http://schemas.openxmlformats.org/drawingml/2006/main">
+            <a:pPr>
+              <a:defRPr sz="1950" b="1">
+                <a:solidFill>
+                  <a:srgbClr val="087F8C"/>
+                </a:solidFill>
+                <a:latin typeface="Arial"/>
+                <a:ea typeface="Arial"/>
+                <a:cs typeface="Arial"/>
+              </a:defRPr>
+            </a:pPr>
+            <a:r>
+              <a:rPr sz="1950" b="1">
+                <a:solidFill>
+                  <a:srgbClr val="087F8C"/>
+                </a:solidFill>
+                <a:latin typeface="Arial"/>
+                <a:ea typeface="Arial"/>
+                <a:cs typeface="Arial"/>
+              </a:rPr>
+              <a:t>Ручні кейси 2.3.0: 2 Pass, 2 Not Run (RGB)</a:t>
             </a:r>
           </a:p>
         </p:txBody>
@@ -14785,7 +15091,7 @@
           <p:cNvPr id="4" name="">
             <a:extLst xmlns:a="http://schemas.openxmlformats.org/drawingml/2006/main">
               <a:ext uri="{FF2B5EF4-FFF2-40B4-BE49-F238E27FC236}">
-                <a16:creationId xmlns:a16="http://schemas.microsoft.com/office/drawing/2014/main" id="{1C4E020B-F359-4082-827F-093CC4D2A076}"/>
+                <a16:creationId xmlns:a16="http://schemas.microsoft.com/office/drawing/2014/main" id="{2600C033-843B-47C4-A558-CBA89D16D3D8}"/>
               </a:ext>
             </a:extLst>
           </p:cNvPr>
@@ -16430,7 +16736,7 @@
           <p:cNvPr id="4" name="">
             <a:extLst xmlns:a="http://schemas.openxmlformats.org/drawingml/2006/main">
               <a:ext uri="{FF2B5EF4-FFF2-40B4-BE49-F238E27FC236}">
-                <a16:creationId xmlns:a16="http://schemas.microsoft.com/office/drawing/2014/main" id="{521C8953-6CFF-4227-9D44-D19AABF712FA}"/>
+                <a16:creationId xmlns:a16="http://schemas.microsoft.com/office/drawing/2014/main" id="{F32F41C4-8505-4E7F-AAD5-5FCEE8B4C8A8}"/>
               </a:ext>
             </a:extLst>
           </p:cNvPr>
@@ -16440,7 +16746,7 @@
           <p:nvPr/>
         </p:nvPicPr>
         <p:blipFill>
-          <a:blip xmlns:r="http://schemas.openxmlformats.org/officeDocument/2006/relationships" xmlns:a="http://schemas.openxmlformats.org/drawingml/2006/main" r:embed="Rfe8342c4756d47d6"/>
+          <a:blip xmlns:r="http://schemas.openxmlformats.org/officeDocument/2006/relationships" xmlns:a="http://schemas.openxmlformats.org/drawingml/2006/main" r:embed="R308b5bea5e664b43"/>
           <a:stretch xmlns:a="http://schemas.openxmlformats.org/drawingml/2006/main"/>
         </p:blipFill>
         <p:spPr>

</xml_diff>

<commit_message>
Record passing manual RGB color checks on 2.3.0
</commit_message>
<xml_diff>
--- a/docs/presentation/SENTRY_SWM2_QA.pptx
+++ b/docs/presentation/SENTRY_SWM2_QA.pptx
@@ -2,22 +2,22 @@
 <file path=ppt/presentation.xml><?xml version="1.0" encoding="utf-8"?>
 <p:presentation xmlns:p="http://schemas.openxmlformats.org/presentationml/2006/main">
   <p:sldMasterIdLst>
-    <p:sldMasterId xmlns:r="http://schemas.openxmlformats.org/officeDocument/2006/relationships" id="2147483648" r:id="R5bc24f22e95e47c5"/>
+    <p:sldMasterId xmlns:r="http://schemas.openxmlformats.org/officeDocument/2006/relationships" id="2147483648" r:id="Ra9f9fa88be9242f7"/>
   </p:sldMasterIdLst>
   <p:notesMasterIdLst>
-    <p:notesMasterId xmlns:r="http://schemas.openxmlformats.org/officeDocument/2006/relationships" r:id="R6fbcf4d7969e4ca0"/>
+    <p:notesMasterId xmlns:r="http://schemas.openxmlformats.org/officeDocument/2006/relationships" r:id="R660f3797b90b4fa1"/>
   </p:notesMasterIdLst>
   <p:sldIdLst>
-    <p:sldId xmlns:r="http://schemas.openxmlformats.org/officeDocument/2006/relationships" id="256" r:id="R25fb744ae368473b"/>
-    <p:sldId xmlns:r="http://schemas.openxmlformats.org/officeDocument/2006/relationships" id="257" r:id="R11d7e20b9713486a"/>
-    <p:sldId xmlns:r="http://schemas.openxmlformats.org/officeDocument/2006/relationships" id="258" r:id="R4748f54bc3e648ab"/>
-    <p:sldId xmlns:r="http://schemas.openxmlformats.org/officeDocument/2006/relationships" id="259" r:id="R8552bcf705024313"/>
-    <p:sldId xmlns:r="http://schemas.openxmlformats.org/officeDocument/2006/relationships" id="260" r:id="Re55aa2d2ccd0463c"/>
-    <p:sldId xmlns:r="http://schemas.openxmlformats.org/officeDocument/2006/relationships" id="261" r:id="R9143af164862423f"/>
-    <p:sldId xmlns:r="http://schemas.openxmlformats.org/officeDocument/2006/relationships" id="262" r:id="R7e57bdb79eba4d8a"/>
-    <p:sldId xmlns:r="http://schemas.openxmlformats.org/officeDocument/2006/relationships" id="263" r:id="R2434542c7f8748ea"/>
-    <p:sldId xmlns:r="http://schemas.openxmlformats.org/officeDocument/2006/relationships" id="264" r:id="R3dd0c6fda5bd42c6"/>
-    <p:sldId xmlns:r="http://schemas.openxmlformats.org/officeDocument/2006/relationships" id="265" r:id="R442b7957f3284a9e"/>
+    <p:sldId xmlns:r="http://schemas.openxmlformats.org/officeDocument/2006/relationships" id="256" r:id="Ra89fc4790af644e4"/>
+    <p:sldId xmlns:r="http://schemas.openxmlformats.org/officeDocument/2006/relationships" id="257" r:id="Rdedaef74a06e44cf"/>
+    <p:sldId xmlns:r="http://schemas.openxmlformats.org/officeDocument/2006/relationships" id="258" r:id="R5b7d6e6196064055"/>
+    <p:sldId xmlns:r="http://schemas.openxmlformats.org/officeDocument/2006/relationships" id="259" r:id="Rdb705af8864a4bc8"/>
+    <p:sldId xmlns:r="http://schemas.openxmlformats.org/officeDocument/2006/relationships" id="260" r:id="Rc5c493d582fd410e"/>
+    <p:sldId xmlns:r="http://schemas.openxmlformats.org/officeDocument/2006/relationships" id="261" r:id="R85c7114952f340ea"/>
+    <p:sldId xmlns:r="http://schemas.openxmlformats.org/officeDocument/2006/relationships" id="262" r:id="R9e6dbc3f16bd4cae"/>
+    <p:sldId xmlns:r="http://schemas.openxmlformats.org/officeDocument/2006/relationships" id="263" r:id="R929f180b738b4dcc"/>
+    <p:sldId xmlns:r="http://schemas.openxmlformats.org/officeDocument/2006/relationships" id="264" r:id="Ra91fd3ec26ef481e"/>
+    <p:sldId xmlns:r="http://schemas.openxmlformats.org/officeDocument/2006/relationships" id="265" r:id="Rabf8ea1321604fdc"/>
   </p:sldIdLst>
   <p:sldSz cx="12192000" cy="6858000"/>
   <p:notesSz cx="6858000" cy="9144000"/>
@@ -536,7 +536,12 @@
           </a:p>
           <a:p xmlns:a="http://schemas.openxmlformats.org/drawingml/2006/main">
             <a:r>
-              <a:t>Ручний прогін 2.3.0, 24.10.2026: TC-RL-02 і TC-RL-03 — Pass за повідомленням виконавця про відповідність усім умовам. Результат включає ON/OFF для обох пар COM–NO/COM–NC і зовнішнього LED. Фото стенда показує обладнання та LED при ON. Окремого UART-логу або відео прозвонювання не надано. Джерело: logs/manual-2.3.0-01/OPERATOR_REPORT.md. TC-LM-09 і TC-LM-10 на 2.3.0 залишаються Not Run. На 2.1.0 усі чотири ручні кейси — Not Run. Підсумок за кейсами 2.3.0: 30 Pass, 3 Fail, 2 Not Run, 1 N/A. Автоматизовані результати та NO-GO не змінені.</a:t>
+              <a:t>Ручний прогін 2.3.0, 24.10.2026: TC-RL-02 і TC-RL-03 — Pass за повідомленням виконавця про відповідність усім умовам. Результат включає ON/OFF для обох пар COM–NO/COM–NC і зовнішнього LED. Фото стенда показує обладнання та LED при ON. Окремого UART-логу або відео прозвонювання не надано. Джерело: logs/manual-2.3.0-01/OPERATOR_REPORT.md. TC-LM-09 на 2.3.0 — Pass для восьми кольорів; TC-LM-10 — Not Run. На 2.1.0 усі чотири ручні кейси — Not Run. Підсумок за кейсами 2.3.0: 31 Pass, 3 Fail, 1 Not Run, 1 N/A. Автоматизовані результати та NO-GO не змінені.</a:t>
+            </a:r>
+          </a:p>
+          <a:p xmlns:a="http://schemas.openxmlformats.org/drawingml/2006/main">
+            <a:r>
+              <a:t>Доповнення 24.10.2026: після інструкції пройти white, red, green, blue, yellow, purple, cyan та orange виконавець повідомив: «перевірив кольори, все ок. Зроби зміни». TC-LM-09 на поточній 2.3.0 — Pass для всіх восьми кольорів. Джерело: logs/manual-2.3.0-01/OPERATOR_REPORT.md, розділ TC-LM-09. Окремі фото або відео кольорів не надано. Залишився TC-LM-10 — яскравість у solid, blink, breathe та rainbow. На 2.1.0 ручні кейси залишаються Not Run.</a:t>
             </a:r>
           </a:p>
         </p:txBody>
@@ -846,7 +851,12 @@
           </a:p>
           <a:p xmlns:a="http://schemas.openxmlformats.org/drawingml/2006/main">
             <a:r>
-              <a:t>Ручний прогін 2.3.0, 24.10.2026: TC-RL-02 і TC-RL-03 — Pass за повідомленням виконавця про відповідність усім умовам. Результат включає ON/OFF для обох пар COM–NO/COM–NC і зовнішнього LED. Фото стенда показує обладнання та LED при ON. Окремого UART-логу або відео прозвонювання не надано. Джерело: logs/manual-2.3.0-01/OPERATOR_REPORT.md. TC-LM-09 і TC-LM-10 на 2.3.0 залишаються Not Run. На 2.1.0 усі чотири ручні кейси — Not Run. Підсумок за кейсами 2.3.0: 30 Pass, 3 Fail, 2 Not Run, 1 N/A. Автоматизовані результати та NO-GO не змінені.</a:t>
+              <a:t>Ручний прогін 2.3.0, 24.10.2026: TC-RL-02 і TC-RL-03 — Pass за повідомленням виконавця про відповідність усім умовам. Результат включає ON/OFF для обох пар COM–NO/COM–NC і зовнішнього LED. Фото стенда показує обладнання та LED при ON. Окремого UART-логу або відео прозвонювання не надано. Джерело: logs/manual-2.3.0-01/OPERATOR_REPORT.md. TC-LM-09 на 2.3.0 — Pass для восьми кольорів; TC-LM-10 — Not Run. На 2.1.0 усі чотири ручні кейси — Not Run. Підсумок за кейсами 2.3.0: 31 Pass, 3 Fail, 1 Not Run, 1 N/A. Автоматизовані результати та NO-GO не змінені.</a:t>
+            </a:r>
+          </a:p>
+          <a:p xmlns:a="http://schemas.openxmlformats.org/drawingml/2006/main">
+            <a:r>
+              <a:t>Доповнення 24.10.2026: після інструкції пройти white, red, green, blue, yellow, purple, cyan та orange виконавець повідомив: «перевірив кольори, все ок. Зроби зміни». TC-LM-09 на поточній 2.3.0 — Pass для всіх восьми кольорів. Джерело: logs/manual-2.3.0-01/OPERATOR_REPORT.md, розділ TC-LM-09. Окремі фото або відео кольорів не надано. Залишився TC-LM-10 — яскравість у solid, blink, breathe та rainbow. На 2.1.0 ручні кейси залишаються Not Run.</a:t>
             </a:r>
           </a:p>
         </p:txBody>
@@ -1001,7 +1011,12 @@
           </a:p>
           <a:p xmlns:a="http://schemas.openxmlformats.org/drawingml/2006/main">
             <a:r>
-              <a:t>Ручний прогін 2.3.0, 24.10.2026: TC-RL-02 і TC-RL-03 — Pass за повідомленням виконавця про відповідність усім умовам. Результат включає ON/OFF для обох пар COM–NO/COM–NC і зовнішнього LED. Фото стенда показує обладнання та LED при ON. Окремого UART-логу або відео прозвонювання не надано. Джерело: logs/manual-2.3.0-01/OPERATOR_REPORT.md. TC-LM-09 і TC-LM-10 на 2.3.0 залишаються Not Run. На 2.1.0 усі чотири ручні кейси — Not Run. Підсумок за кейсами 2.3.0: 30 Pass, 3 Fail, 2 Not Run, 1 N/A. Автоматизовані результати та NO-GO не змінені.</a:t>
+              <a:t>Ручний прогін 2.3.0, 24.10.2026: TC-RL-02 і TC-RL-03 — Pass за повідомленням виконавця про відповідність усім умовам. Результат включає ON/OFF для обох пар COM–NO/COM–NC і зовнішнього LED. Фото стенда показує обладнання та LED при ON. Окремого UART-логу або відео прозвонювання не надано. Джерело: logs/manual-2.3.0-01/OPERATOR_REPORT.md. TC-LM-09 на 2.3.0 — Pass для восьми кольорів; TC-LM-10 — Not Run. На 2.1.0 усі чотири ручні кейси — Not Run. Підсумок за кейсами 2.3.0: 31 Pass, 3 Fail, 1 Not Run, 1 N/A. Автоматизовані результати та NO-GO не змінені.</a:t>
+            </a:r>
+          </a:p>
+          <a:p xmlns:a="http://schemas.openxmlformats.org/drawingml/2006/main">
+            <a:r>
+              <a:t>Доповнення 24.10.2026: після інструкції пройти white, red, green, blue, yellow, purple, cyan та orange виконавець повідомив: «перевірив кольори, все ок. Зроби зміни». TC-LM-09 на поточній 2.3.0 — Pass для всіх восьми кольорів. Джерело: logs/manual-2.3.0-01/OPERATOR_REPORT.md, розділ TC-LM-09. Окремі фото або відео кольорів не надано. Залишився TC-LM-10 — яскравість у solid, blink, breathe та rainbow. На 2.1.0 ручні кейси залишаються Not Run.</a:t>
             </a:r>
           </a:p>
         </p:txBody>
@@ -3624,12 +3639,12 @@
   </p:cSld>
   <p:clrMap bg1="lt1" tx1="dk1" bg2="lt2" tx2="dk2" accent1="accent1" accent2="accent2" accent3="accent3" accent4="accent4" accent5="accent5" accent6="accent6" hlink="hlink" folHlink="folHlink"/>
   <p:sldLayoutIdLst>
-    <p:sldLayoutId xmlns:r="http://schemas.openxmlformats.org/officeDocument/2006/relationships" id="2147483649" r:id="Rc5f9c11d28784848"/>
-    <p:sldLayoutId xmlns:r="http://schemas.openxmlformats.org/officeDocument/2006/relationships" id="2147483650" r:id="R17b06670b6614e81"/>
-    <p:sldLayoutId xmlns:r="http://schemas.openxmlformats.org/officeDocument/2006/relationships" id="2147483651" r:id="R1881d436e7784b73"/>
-    <p:sldLayoutId xmlns:r="http://schemas.openxmlformats.org/officeDocument/2006/relationships" id="2147483652" r:id="R21f8e35de54c45ba"/>
-    <p:sldLayoutId xmlns:r="http://schemas.openxmlformats.org/officeDocument/2006/relationships" id="2147483653" r:id="Rc51e8588ff0e4692"/>
-    <p:sldLayoutId xmlns:r="http://schemas.openxmlformats.org/officeDocument/2006/relationships" id="2147483654" r:id="R4b9ccef4bf264e30"/>
+    <p:sldLayoutId xmlns:r="http://schemas.openxmlformats.org/officeDocument/2006/relationships" id="2147483649" r:id="R6295f3aa632e4b6e"/>
+    <p:sldLayoutId xmlns:r="http://schemas.openxmlformats.org/officeDocument/2006/relationships" id="2147483650" r:id="R6ced7e40b92448fb"/>
+    <p:sldLayoutId xmlns:r="http://schemas.openxmlformats.org/officeDocument/2006/relationships" id="2147483651" r:id="Rfca98e8b03a547fb"/>
+    <p:sldLayoutId xmlns:r="http://schemas.openxmlformats.org/officeDocument/2006/relationships" id="2147483652" r:id="Ra8e14d8a24564df9"/>
+    <p:sldLayoutId xmlns:r="http://schemas.openxmlformats.org/officeDocument/2006/relationships" id="2147483653" r:id="R655cecf0931b4dc8"/>
+    <p:sldLayoutId xmlns:r="http://schemas.openxmlformats.org/officeDocument/2006/relationships" id="2147483654" r:id="R6ad261a8431b4664"/>
   </p:sldLayoutIdLst>
   <p:txStyles>
     <p:titleStyle>
@@ -5907,7 +5922,7 @@
                 <a:ea typeface="Arial"/>
                 <a:cs typeface="Arial"/>
               </a:rPr>
-              <a:t>Реле й зовнішній LED: Pass на 2.3.0.</a:t>
+              <a:t>Реле, зовнішній LED і кольори RGB: Pass на 2.3.0.</a:t>
             </a:r>
           </a:p>
           <a:p xmlns:a="http://schemas.openxmlformats.org/drawingml/2006/main">
@@ -5931,7 +5946,7 @@
                 <a:ea typeface="Arial"/>
                 <a:cs typeface="Arial"/>
               </a:rPr>
-              <a:t>Кольори RGB та яскравість: Not Run.</a:t>
+              <a:t>Яскравість у чотирьох режимах: Not Run.</a:t>
             </a:r>
           </a:p>
         </p:txBody>
@@ -7038,7 +7053,7 @@
           <p:cNvPr id="8" name="">
             <a:extLst xmlns:a="http://schemas.openxmlformats.org/drawingml/2006/main">
               <a:ext uri="{FF2B5EF4-FFF2-40B4-BE49-F238E27FC236}">
-                <a16:creationId xmlns:a16="http://schemas.microsoft.com/office/drawing/2014/main" id="{7F3DC05D-8E73-4023-8E38-13BF7B897BFB}"/>
+                <a16:creationId xmlns:a16="http://schemas.microsoft.com/office/drawing/2014/main" id="{3C775D36-6C8C-47A7-82F2-D3267436F3E4}"/>
               </a:ext>
             </a:extLst>
           </p:cNvPr>
@@ -7048,7 +7063,7 @@
           <p:nvPr/>
         </p:nvPicPr>
         <p:blipFill>
-          <a:blip xmlns:r="http://schemas.openxmlformats.org/officeDocument/2006/relationships" xmlns:a="http://schemas.openxmlformats.org/drawingml/2006/main" r:embed="R68b108181edf44ca"/>
+          <a:blip xmlns:r="http://schemas.openxmlformats.org/officeDocument/2006/relationships" xmlns:a="http://schemas.openxmlformats.org/drawingml/2006/main" r:embed="R04a7ea5e76904f00"/>
           <a:stretch xmlns:a="http://schemas.openxmlformats.org/drawingml/2006/main"/>
         </p:blipFill>
         <p:spPr>
@@ -7593,7 +7608,7 @@
           <p:cNvPr id="4" name="">
             <a:extLst xmlns:a="http://schemas.openxmlformats.org/drawingml/2006/main">
               <a:ext uri="{FF2B5EF4-FFF2-40B4-BE49-F238E27FC236}">
-                <a16:creationId xmlns:a16="http://schemas.microsoft.com/office/drawing/2014/main" id="{F139A91F-8E28-41E6-ABA1-0295AFFC8787}"/>
+                <a16:creationId xmlns:a16="http://schemas.microsoft.com/office/drawing/2014/main" id="{F072F97F-69E2-4737-A060-ECD51F31A832}"/>
               </a:ext>
             </a:extLst>
           </p:cNvPr>
@@ -10292,7 +10307,7 @@
           <p:cNvPr id="2" name="">
             <a:extLst xmlns:a="http://schemas.openxmlformats.org/drawingml/2006/main">
               <a:ext uri="{FF2B5EF4-FFF2-40B4-BE49-F238E27FC236}">
-                <a16:creationId xmlns:a16="http://schemas.microsoft.com/office/drawing/2014/main" id="{ADE7CB45-3180-4B77-A2FF-3947EAA4ABD4}"/>
+                <a16:creationId xmlns:a16="http://schemas.microsoft.com/office/drawing/2014/main" id="{7432A7A9-0354-4292-9AD5-849B47ADAC9E}"/>
               </a:ext>
             </a:extLst>
           </p:cNvPr>
@@ -10302,7 +10317,7 @@
           <p:nvPr/>
         </p:nvPicPr>
         <p:blipFill>
-          <a:blip xmlns:r="http://schemas.openxmlformats.org/officeDocument/2006/relationships" xmlns:a="http://schemas.openxmlformats.org/drawingml/2006/main" r:embed="R470e512c81d84189"/>
+          <a:blip xmlns:r="http://schemas.openxmlformats.org/officeDocument/2006/relationships" xmlns:a="http://schemas.openxmlformats.org/drawingml/2006/main" r:embed="Rf179e6ed52c04930"/>
           <a:stretch xmlns:a="http://schemas.openxmlformats.org/drawingml/2006/main"/>
         </p:blipFill>
         <p:spPr>
@@ -11804,7 +11819,7 @@
                 <a:ea typeface="Arial"/>
                 <a:cs typeface="Arial"/>
               </a:rPr>
-              <a:t>2.3.0: реле та зовнішній LED — Pass.</a:t>
+              <a:t>2.3.0: реле, LED та кольори RGB — Pass.</a:t>
             </a:r>
           </a:p>
           <a:p xmlns:a="http://schemas.openxmlformats.org/drawingml/2006/main">
@@ -12365,7 +12380,7 @@
           <p:cNvPr id="4" name="">
             <a:extLst xmlns:a="http://schemas.openxmlformats.org/drawingml/2006/main">
               <a:ext uri="{FF2B5EF4-FFF2-40B4-BE49-F238E27FC236}">
-                <a16:creationId xmlns:a16="http://schemas.microsoft.com/office/drawing/2014/main" id="{F2E2F041-8D30-4C5A-874E-F0AC3F21F978}"/>
+                <a16:creationId xmlns:a16="http://schemas.microsoft.com/office/drawing/2014/main" id="{E4E30461-FA01-4AF7-8CD6-F62B537501A0}"/>
               </a:ext>
             </a:extLst>
           </p:cNvPr>
@@ -13593,7 +13608,7 @@
           <p:cNvPr id="4" name="">
             <a:extLst xmlns:a="http://schemas.openxmlformats.org/drawingml/2006/main">
               <a:ext uri="{FF2B5EF4-FFF2-40B4-BE49-F238E27FC236}">
-                <a16:creationId xmlns:a16="http://schemas.microsoft.com/office/drawing/2014/main" id="{F199FFCD-5E78-45A4-A50E-ED7155A0A86D}"/>
+                <a16:creationId xmlns:a16="http://schemas.microsoft.com/office/drawing/2014/main" id="{475D0AC4-B855-4E2C-93D9-740E0FB45DE9}"/>
               </a:ext>
             </a:extLst>
           </p:cNvPr>
@@ -14610,6 +14625,7 @@
               </a:defRPr>
             </a:defPPr>
             <a:lvl1pPr>
+              <a:buNone/>
               <a:defRPr sz="1950" b="1">
                 <a:solidFill>
                   <a:srgbClr val="087F8C"/>
@@ -14620,6 +14636,7 @@
               </a:defRPr>
             </a:lvl1pPr>
             <a:lvl2pPr>
+              <a:buNone/>
               <a:defRPr sz="1950" b="1">
                 <a:solidFill>
                   <a:srgbClr val="087F8C"/>
@@ -14630,6 +14647,7 @@
               </a:defRPr>
             </a:lvl2pPr>
             <a:lvl3pPr>
+              <a:buNone/>
               <a:defRPr sz="1950" b="1">
                 <a:solidFill>
                   <a:srgbClr val="087F8C"/>
@@ -14640,6 +14658,7 @@
               </a:defRPr>
             </a:lvl3pPr>
             <a:lvl4pPr>
+              <a:buNone/>
               <a:defRPr sz="1950" b="1">
                 <a:solidFill>
                   <a:srgbClr val="087F8C"/>
@@ -14650,6 +14669,7 @@
               </a:defRPr>
             </a:lvl4pPr>
             <a:lvl5pPr>
+              <a:buNone/>
               <a:defRPr sz="1950" b="1">
                 <a:solidFill>
                   <a:srgbClr val="087F8C"/>
@@ -14660,6 +14680,7 @@
               </a:defRPr>
             </a:lvl5pPr>
             <a:lvl6pPr>
+              <a:buNone/>
               <a:defRPr sz="1950" b="1">
                 <a:solidFill>
                   <a:srgbClr val="087F8C"/>
@@ -14670,6 +14691,7 @@
               </a:defRPr>
             </a:lvl6pPr>
             <a:lvl7pPr>
+              <a:buNone/>
               <a:defRPr sz="1950" b="1">
                 <a:solidFill>
                   <a:srgbClr val="087F8C"/>
@@ -14680,6 +14702,7 @@
               </a:defRPr>
             </a:lvl7pPr>
             <a:lvl8pPr>
+              <a:buNone/>
               <a:defRPr sz="1950" b="1">
                 <a:solidFill>
                   <a:srgbClr val="087F8C"/>
@@ -14690,6 +14713,7 @@
               </a:defRPr>
             </a:lvl8pPr>
             <a:lvl9pPr>
+              <a:buNone/>
               <a:defRPr sz="1950" b="1">
                 <a:solidFill>
                   <a:srgbClr val="087F8C"/>
@@ -14702,6 +14726,7 @@
           </a:lstStyle>
           <a:p xmlns:a="http://schemas.openxmlformats.org/drawingml/2006/main">
             <a:pPr>
+              <a:buNone/>
               <a:defRPr sz="1950" b="1">
                 <a:solidFill>
                   <a:srgbClr val="087F8C"/>
@@ -14720,7 +14745,7 @@
                 <a:ea typeface="Arial"/>
                 <a:cs typeface="Arial"/>
               </a:rPr>
-              <a:t>Ручні кейси 2.3.0: 2 Pass, 2 Not Run (RGB)</a:t>
+              <a:t>Ручні кейси 2.3.0: 3 Pass, 1 Not Run (яскравість)</a:t>
             </a:r>
           </a:p>
         </p:txBody>
@@ -15091,7 +15116,7 @@
           <p:cNvPr id="4" name="">
             <a:extLst xmlns:a="http://schemas.openxmlformats.org/drawingml/2006/main">
               <a:ext uri="{FF2B5EF4-FFF2-40B4-BE49-F238E27FC236}">
-                <a16:creationId xmlns:a16="http://schemas.microsoft.com/office/drawing/2014/main" id="{2600C033-843B-47C4-A558-CBA89D16D3D8}"/>
+                <a16:creationId xmlns:a16="http://schemas.microsoft.com/office/drawing/2014/main" id="{D992BAB9-397B-41AE-ABFC-71EA359D4063}"/>
               </a:ext>
             </a:extLst>
           </p:cNvPr>
@@ -16736,7 +16761,7 @@
           <p:cNvPr id="4" name="">
             <a:extLst xmlns:a="http://schemas.openxmlformats.org/drawingml/2006/main">
               <a:ext uri="{FF2B5EF4-FFF2-40B4-BE49-F238E27FC236}">
-                <a16:creationId xmlns:a16="http://schemas.microsoft.com/office/drawing/2014/main" id="{F32F41C4-8505-4E7F-AAD5-5FCEE8B4C8A8}"/>
+                <a16:creationId xmlns:a16="http://schemas.microsoft.com/office/drawing/2014/main" id="{2FBC3BDC-EC50-47C2-AAE5-EE2EAFD15A09}"/>
               </a:ext>
             </a:extLst>
           </p:cNvPr>
@@ -16746,7 +16771,7 @@
           <p:nvPr/>
         </p:nvPicPr>
         <p:blipFill>
-          <a:blip xmlns:r="http://schemas.openxmlformats.org/officeDocument/2006/relationships" xmlns:a="http://schemas.openxmlformats.org/drawingml/2006/main" r:embed="R308b5bea5e664b43"/>
+          <a:blip xmlns:r="http://schemas.openxmlformats.org/officeDocument/2006/relationships" xmlns:a="http://schemas.openxmlformats.org/drawingml/2006/main" r:embed="Rae0e6a056ab44e0f"/>
           <a:stretch xmlns:a="http://schemas.openxmlformats.org/drawingml/2006/main"/>
         </p:blipFill>
         <p:spPr>

</xml_diff>